<commit_message>
Fix chart axis declarations and add standalone Littleton brief slide
Every chart emitted three <c:axId> children on its plot element while
declaring only two axes (no serAx for the third id). That is schema-legal
so the validator accepted it, but PowerPoint expects exactly two on a 2-D
chart and can discard the chart — most visibly on the Littleton slide,
whose bar-plus-target-line combo carries two plot elements.

- Strip the stray third axId from every chart in the deck
- Add a standalone one-slide file of the Littleton administrator brief,
  same 13.333x7.5 canvas so it drops straight into the deck

Co-Authored-By: Claude Opus 5 <noreply@anthropic.com>
Claude-Session: https://claude.ai/code/session_01CmmBiP3tmxSPb1WG4seoh5
</commit_message>
<xml_diff>
--- a/Three Plans One Cluster - Cluster Deck.pptx
+++ b/Three Plans One Cluster - Cluster Deck.pptx
@@ -332,7 +332,6 @@
         <c:overlap val="100"/>
         <c:axId val="2094734554"/>
         <c:axId val="2094734552"/>
-        <c:axId val="2094734556"/>
       </c:barChart>
       <c:catAx>
         <c:axId val="2094734554"/>
@@ -614,7 +613,6 @@
         <c:overlap val="0"/>
         <c:axId val="2094734554"/>
         <c:axId val="2094734552"/>
-        <c:axId val="2094734556"/>
       </c:barChart>
       <c:lineChart>
         <c:varyColors val="0"/>
@@ -773,7 +771,6 @@
         <c:marker val="1"/>
         <c:axId val="2094734554"/>
         <c:axId val="2094734552"/>
-        <c:axId val="2094734556"/>
       </c:lineChart>
       <c:catAx>
         <c:axId val="2094734554"/>
@@ -1176,7 +1173,6 @@
         <c:marker val="1"/>
         <c:axId val="2094734554"/>
         <c:axId val="2094734552"/>
-        <c:axId val="2094734556"/>
       </c:lineChart>
       <c:catAx>
         <c:axId val="2094734554"/>

</xml_diff>